<commit_message>
add snu theme (signature navy #0F0F70 / gold #C5A86F) + re-theme benchmark
The original reference identity this toolkit was built from. snu.json mirrors the
design_system.html tokens; snu_components.xml is the canonical OOXML clone, so the
recolor map is identity and PowerPoint renders the gold pill/cards/number-block in
the true reference colors. Benchmark deck + 2x3 gallery re-themed skku -> snu.
</commit_message>
<xml_diff>
--- a/samples/benchmark_catalysis_deck.pptx
+++ b/samples/benchmark_catalysis_deck.pptx
@@ -3152,7 +3152,7 @@
             <a:avLst/>
           </a:prstGeom>
           <a:solidFill>
-            <a:srgbClr val="072B61"/>
+            <a:srgbClr val="0F0F70"/>
           </a:solidFill>
           <a:ln>
             <a:noFill/>
@@ -3181,33 +3181,9 @@
           </a:p>
         </p:txBody>
       </p:sp>
-      <p:pic>
-        <p:nvPicPr>
-          <p:cNvPr id="4" name="Picture 3" descr="skku.png"/>
-          <p:cNvPicPr>
-            <a:picLocks noChangeAspect="1"/>
-          </p:cNvPicPr>
-          <p:nvPr/>
-        </p:nvPicPr>
-        <p:blipFill>
-          <a:blip r:embed="rId2"/>
-          <a:stretch>
-            <a:fillRect/>
-          </a:stretch>
-        </p:blipFill>
-        <p:spPr>
-          <a:xfrm>
-            <a:off x="857250" y="571500"/>
-            <a:ext cx="3153659" cy="590550"/>
-          </a:xfrm>
-          <a:prstGeom prst="rect">
-            <a:avLst/>
-          </a:prstGeom>
-        </p:spPr>
-      </p:pic>
-      <p:sp>
-        <p:nvSpPr>
-          <p:cNvPr id="5" name="TextBox 4"/>
+      <p:sp>
+        <p:nvSpPr>
+          <p:cNvPr id="4" name="TextBox 3"/>
           <p:cNvSpPr txBox="1"/>
           <p:nvPr/>
         </p:nvSpPr>
@@ -3231,7 +3207,7 @@
             <a:r>
               <a:rPr sz="4000" b="1">
                 <a:solidFill>
-                  <a:srgbClr val="072B61"/>
+                  <a:srgbClr val="0F0F70"/>
                 </a:solidFill>
                 <a:latin typeface="Arial"/>
                 <a:ea typeface="Malgun Gothic"/>
@@ -3243,7 +3219,7 @@
       </p:sp>
       <p:sp>
         <p:nvSpPr>
-          <p:cNvPr id="6" name="Rectangle 5"/>
+          <p:cNvPr id="5" name="Rectangle 4"/>
           <p:cNvSpPr/>
           <p:nvPr/>
         </p:nvSpPr>
@@ -3256,7 +3232,7 @@
             <a:avLst/>
           </a:prstGeom>
           <a:solidFill>
-            <a:srgbClr val="8DC63F"/>
+            <a:srgbClr val="C5A86F"/>
           </a:solidFill>
           <a:ln>
             <a:noFill/>
@@ -3287,7 +3263,7 @@
       </p:sp>
       <p:sp>
         <p:nvSpPr>
-          <p:cNvPr id="7" name="TextBox 6"/>
+          <p:cNvPr id="6" name="TextBox 5"/>
           <p:cNvSpPr txBox="1"/>
           <p:nvPr/>
         </p:nvSpPr>
@@ -3323,7 +3299,7 @@
       </p:sp>
       <p:sp>
         <p:nvSpPr>
-          <p:cNvPr id="8" name="Rectangle 7"/>
+          <p:cNvPr id="7" name="Rectangle 6"/>
           <p:cNvSpPr/>
           <p:nvPr/>
         </p:nvSpPr>
@@ -3336,7 +3312,7 @@
             <a:avLst/>
           </a:prstGeom>
           <a:solidFill>
-            <a:srgbClr val="072B61"/>
+            <a:srgbClr val="0F0F70"/>
           </a:solidFill>
           <a:ln>
             <a:noFill/>
@@ -3367,7 +3343,7 @@
       </p:sp>
       <p:sp>
         <p:nvSpPr>
-          <p:cNvPr id="9" name="TextBox 8"/>
+          <p:cNvPr id="8" name="TextBox 7"/>
           <p:cNvSpPr txBox="1"/>
           <p:nvPr/>
         </p:nvSpPr>
@@ -3403,7 +3379,7 @@
       </p:sp>
       <p:sp>
         <p:nvSpPr>
-          <p:cNvPr id="10" name="TextBox 9"/>
+          <p:cNvPr id="9" name="TextBox 8"/>
           <p:cNvSpPr txBox="1"/>
           <p:nvPr/>
         </p:nvSpPr>
@@ -3472,12 +3448,12 @@
           <a:gradFill>
             <a:gsLst>
               <a:gs pos="0">
-                <a:srgbClr val="E8EFE1">
+                <a:srgbClr val="E9E9F2">
                   <a:alpha val="100000"/>
                 </a:srgbClr>
               </a:gs>
               <a:gs pos="60000">
-                <a:srgbClr val="E8EFE1">
+                <a:srgbClr val="E9E9F2">
                   <a:alpha val="35000"/>
                 </a:srgbClr>
               </a:gs>
@@ -3533,10 +3509,10 @@
           <a:gradFill flip="none" rotWithShape="1">
             <a:gsLst>
               <a:gs pos="11000">
-                <a:srgbClr val="04193D"/>
+                <a:srgbClr val="060634"/>
               </a:gs>
               <a:gs pos="56000">
-                <a:srgbClr val="072B61"/>
+                <a:srgbClr val="0F0F70"/>
               </a:gs>
             </a:gsLst>
             <a:lin ang="18900000" scaled="1"/>
@@ -3712,7 +3688,7 @@
             </a:avLst>
           </a:prstGeom>
           <a:solidFill>
-            <a:srgbClr val="8DC63F"/>
+            <a:srgbClr val="C5A86F"/>
           </a:solidFill>
           <a:ln>
             <a:noFill/>
@@ -3742,7 +3718,7 @@
             <a:r>
               <a:rPr lang="en-US" altLang="ko-KR" dirty="0">
                 <a:solidFill>
-                  <a:srgbClr val="072B61"/>
+                  <a:srgbClr val="FFFFFF"/>
                 </a:solidFill>
                 <a:latin typeface="Arial" panose="020B0604020202020204" pitchFamily="34" charset="0"/>
                 <a:cs typeface="Arial" panose="020B0604020202020204" pitchFamily="34" charset="0"/>
@@ -3811,7 +3787,7 @@
             <a:avLst/>
           </a:prstGeom>
           <a:solidFill>
-            <a:srgbClr val="072B61"/>
+            <a:srgbClr val="0F0F70"/>
           </a:solidFill>
           <a:ln>
             <a:noFill/>
@@ -3893,7 +3869,7 @@
             <a:r>
               <a:rPr sz="1700" b="1">
                 <a:solidFill>
-                  <a:srgbClr val="8DC63F"/>
+                  <a:srgbClr val="C5A86F"/>
                 </a:solidFill>
                 <a:latin typeface="Arial"/>
                 <a:ea typeface="Malgun Gothic"/>
@@ -3913,7 +3889,7 @@
             <a:r>
               <a:rPr b="1" sz="1700">
                 <a:solidFill>
-                  <a:srgbClr val="072B61"/>
+                  <a:srgbClr val="0F0F70"/>
                 </a:solidFill>
                 <a:latin typeface="Arial"/>
                 <a:ea typeface="Malgun Gothic"/>
@@ -3933,7 +3909,7 @@
             <a:r>
               <a:rPr b="1" sz="1700">
                 <a:solidFill>
-                  <a:srgbClr val="124633"/>
+                  <a:srgbClr val="840032"/>
                 </a:solidFill>
                 <a:latin typeface="Arial"/>
                 <a:ea typeface="Malgun Gothic"/>
@@ -3960,7 +3936,7 @@
             <a:r>
               <a:rPr sz="1700" b="1">
                 <a:solidFill>
-                  <a:srgbClr val="8DC63F"/>
+                  <a:srgbClr val="C5A86F"/>
                 </a:solidFill>
                 <a:latin typeface="Arial"/>
                 <a:ea typeface="Malgun Gothic"/>
@@ -3980,7 +3956,7 @@
             <a:r>
               <a:rPr b="1" sz="1700">
                 <a:solidFill>
-                  <a:srgbClr val="072B61"/>
+                  <a:srgbClr val="0F0F70"/>
                 </a:solidFill>
                 <a:latin typeface="Arial"/>
                 <a:ea typeface="Malgun Gothic"/>
@@ -4007,7 +3983,7 @@
             <a:r>
               <a:rPr sz="1700" b="1">
                 <a:solidFill>
-                  <a:srgbClr val="8DC63F"/>
+                  <a:srgbClr val="C5A86F"/>
                 </a:solidFill>
                 <a:latin typeface="Arial"/>
                 <a:ea typeface="Malgun Gothic"/>
@@ -4017,7 +3993,7 @@
             <a:r>
               <a:rPr b="1" sz="1700">
                 <a:solidFill>
-                  <a:srgbClr val="124633"/>
+                  <a:srgbClr val="840032"/>
                 </a:solidFill>
                 <a:latin typeface="Arial"/>
                 <a:ea typeface="Malgun Gothic"/>
@@ -4037,7 +4013,7 @@
             <a:r>
               <a:rPr b="1" sz="1700">
                 <a:solidFill>
-                  <a:srgbClr val="072B61"/>
+                  <a:srgbClr val="0F0F70"/>
                 </a:solidFill>
                 <a:latin typeface="Arial"/>
                 <a:ea typeface="Malgun Gothic"/>
@@ -4093,7 +4069,7 @@
             <a:r>
               <a:rPr b="1" sz="1700">
                 <a:solidFill>
-                  <a:srgbClr val="124633"/>
+                  <a:srgbClr val="840032"/>
                 </a:solidFill>
                 <a:latin typeface="Arial"/>
                 <a:ea typeface="Malgun Gothic"/>
@@ -4113,7 +4089,7 @@
             <a:r>
               <a:rPr b="1" sz="1700">
                 <a:solidFill>
-                  <a:srgbClr val="124633"/>
+                  <a:srgbClr val="840032"/>
                 </a:solidFill>
                 <a:latin typeface="Arial"/>
                 <a:ea typeface="Malgun Gothic"/>
@@ -4133,7 +4109,7 @@
             <a:r>
               <a:rPr b="1" sz="1700">
                 <a:solidFill>
-                  <a:srgbClr val="072B61"/>
+                  <a:srgbClr val="0F0F70"/>
                 </a:solidFill>
                 <a:latin typeface="Arial"/>
                 <a:ea typeface="Malgun Gothic"/>
@@ -4178,7 +4154,7 @@
             <a:r>
               <a:rPr sz="1400" i="1">
                 <a:solidFill>
-                  <a:srgbClr val="7C7C7C"/>
+                  <a:srgbClr val="697A82"/>
                 </a:solidFill>
                 <a:latin typeface="Arial"/>
                 <a:ea typeface="Malgun Gothic"/>
@@ -4188,7 +4164,7 @@
             <a:r>
               <a:rPr b="1" sz="1400" i="1">
                 <a:solidFill>
-                  <a:srgbClr val="FF6C0F"/>
+                  <a:srgbClr val="840032"/>
                 </a:solidFill>
                 <a:latin typeface="Arial"/>
                 <a:ea typeface="Malgun Gothic"/>
@@ -4233,12 +4209,12 @@
           <a:gradFill>
             <a:gsLst>
               <a:gs pos="0">
-                <a:srgbClr val="E8EFE1">
+                <a:srgbClr val="E9E9F2">
                   <a:alpha val="100000"/>
                 </a:srgbClr>
               </a:gs>
               <a:gs pos="60000">
-                <a:srgbClr val="E8EFE1">
+                <a:srgbClr val="E9E9F2">
                   <a:alpha val="35000"/>
                 </a:srgbClr>
               </a:gs>
@@ -4294,10 +4270,10 @@
           <a:gradFill flip="none" rotWithShape="1">
             <a:gsLst>
               <a:gs pos="11000">
-                <a:srgbClr val="04193D"/>
+                <a:srgbClr val="060634"/>
               </a:gs>
               <a:gs pos="56000">
-                <a:srgbClr val="072B61"/>
+                <a:srgbClr val="0F0F70"/>
               </a:gs>
             </a:gsLst>
             <a:lin ang="18900000" scaled="1"/>
@@ -4473,7 +4449,7 @@
             </a:avLst>
           </a:prstGeom>
           <a:solidFill>
-            <a:srgbClr val="8DC63F"/>
+            <a:srgbClr val="C5A86F"/>
           </a:solidFill>
           <a:ln>
             <a:noFill/>
@@ -4503,7 +4479,7 @@
             <a:r>
               <a:rPr lang="en-US" altLang="ko-KR" dirty="0">
                 <a:solidFill>
-                  <a:srgbClr val="072B61"/>
+                  <a:srgbClr val="FFFFFF"/>
                 </a:solidFill>
                 <a:latin typeface="Arial" panose="020B0604020202020204" pitchFamily="34" charset="0"/>
                 <a:cs typeface="Arial" panose="020B0604020202020204" pitchFamily="34" charset="0"/>
@@ -4578,7 +4554,7 @@
           </a:solidFill>
           <a:ln w="28575">
             <a:solidFill>
-              <a:srgbClr val="072B61"/>
+              <a:srgbClr val="0F0F70"/>
             </a:solidFill>
           </a:ln>
         </p:spPr>
@@ -4637,7 +4613,7 @@
             <a:r>
               <a:rPr sz="2000" b="1">
                 <a:solidFill>
-                  <a:srgbClr val="072B61"/>
+                  <a:srgbClr val="0F0F70"/>
                 </a:solidFill>
                 <a:latin typeface="Arial"/>
                 <a:ea typeface="Malgun Gothic"/>
@@ -4660,7 +4636,7 @@
             <a:r>
               <a:rPr b="1" sz="1700">
                 <a:solidFill>
-                  <a:srgbClr val="124633"/>
+                  <a:srgbClr val="840032"/>
                 </a:solidFill>
                 <a:latin typeface="Arial"/>
                 <a:ea typeface="Malgun Gothic"/>
@@ -4680,7 +4656,7 @@
             <a:r>
               <a:rPr b="1" sz="1700">
                 <a:solidFill>
-                  <a:srgbClr val="124633"/>
+                  <a:srgbClr val="840032"/>
                 </a:solidFill>
                 <a:latin typeface="Arial"/>
                 <a:ea typeface="Malgun Gothic"/>
@@ -4721,7 +4697,7 @@
           </a:solidFill>
           <a:ln w="28575">
             <a:solidFill>
-              <a:srgbClr val="8DC63F"/>
+              <a:srgbClr val="C5A86F"/>
             </a:solidFill>
           </a:ln>
         </p:spPr>
@@ -4780,7 +4756,7 @@
             <a:r>
               <a:rPr sz="2000" b="1">
                 <a:solidFill>
-                  <a:srgbClr val="124633"/>
+                  <a:srgbClr val="840032"/>
                 </a:solidFill>
                 <a:latin typeface="Arial"/>
                 <a:ea typeface="Malgun Gothic"/>
@@ -4803,7 +4779,7 @@
             <a:r>
               <a:rPr b="1" sz="1700">
                 <a:solidFill>
-                  <a:srgbClr val="072B61"/>
+                  <a:srgbClr val="0F0F70"/>
                 </a:solidFill>
                 <a:latin typeface="Arial"/>
                 <a:ea typeface="Malgun Gothic"/>
@@ -4823,7 +4799,7 @@
             <a:r>
               <a:rPr b="1" sz="1700">
                 <a:solidFill>
-                  <a:srgbClr val="124633"/>
+                  <a:srgbClr val="840032"/>
                 </a:solidFill>
                 <a:latin typeface="Arial"/>
                 <a:ea typeface="Malgun Gothic"/>
@@ -4864,7 +4840,7 @@
           </a:solidFill>
           <a:ln w="28575">
             <a:solidFill>
-              <a:srgbClr val="072B61"/>
+              <a:srgbClr val="0F0F70"/>
             </a:solidFill>
           </a:ln>
         </p:spPr>
@@ -4923,7 +4899,7 @@
             <a:r>
               <a:rPr sz="2000" b="1">
                 <a:solidFill>
-                  <a:srgbClr val="072B61"/>
+                  <a:srgbClr val="0F0F70"/>
                 </a:solidFill>
                 <a:latin typeface="Arial"/>
                 <a:ea typeface="Malgun Gothic"/>
@@ -4946,7 +4922,7 @@
             <a:r>
               <a:rPr b="1" sz="1700">
                 <a:solidFill>
-                  <a:srgbClr val="072B61"/>
+                  <a:srgbClr val="0F0F70"/>
                 </a:solidFill>
                 <a:latin typeface="Arial"/>
                 <a:ea typeface="Malgun Gothic"/>
@@ -4966,7 +4942,7 @@
             <a:r>
               <a:rPr b="1" sz="1700">
                 <a:solidFill>
-                  <a:srgbClr val="124633"/>
+                  <a:srgbClr val="840032"/>
                 </a:solidFill>
                 <a:latin typeface="Arial"/>
                 <a:ea typeface="Malgun Gothic"/>
@@ -5011,7 +4987,7 @@
             <a:r>
               <a:rPr sz="1400" i="1">
                 <a:solidFill>
-                  <a:srgbClr val="7C7C7C"/>
+                  <a:srgbClr val="697A82"/>
                 </a:solidFill>
                 <a:latin typeface="Arial"/>
                 <a:ea typeface="Malgun Gothic"/>
@@ -5021,7 +4997,7 @@
             <a:r>
               <a:rPr b="1" sz="1400" i="1">
                 <a:solidFill>
-                  <a:srgbClr val="FF6C0F"/>
+                  <a:srgbClr val="840032"/>
                 </a:solidFill>
                 <a:latin typeface="Arial"/>
                 <a:ea typeface="Malgun Gothic"/>
@@ -5031,7 +5007,7 @@
             <a:r>
               <a:rPr sz="1400" i="1">
                 <a:solidFill>
-                  <a:srgbClr val="7C7C7C"/>
+                  <a:srgbClr val="697A82"/>
                 </a:solidFill>
                 <a:latin typeface="Arial"/>
                 <a:ea typeface="Malgun Gothic"/>
@@ -5076,12 +5052,12 @@
           <a:gradFill>
             <a:gsLst>
               <a:gs pos="0">
-                <a:srgbClr val="E8EFE1">
+                <a:srgbClr val="E9E9F2">
                   <a:alpha val="100000"/>
                 </a:srgbClr>
               </a:gs>
               <a:gs pos="60000">
-                <a:srgbClr val="E8EFE1">
+                <a:srgbClr val="E9E9F2">
                   <a:alpha val="35000"/>
                 </a:srgbClr>
               </a:gs>
@@ -5137,10 +5113,10 @@
           <a:gradFill flip="none" rotWithShape="1">
             <a:gsLst>
               <a:gs pos="11000">
-                <a:srgbClr val="04193D"/>
+                <a:srgbClr val="060634"/>
               </a:gs>
               <a:gs pos="56000">
-                <a:srgbClr val="072B61"/>
+                <a:srgbClr val="0F0F70"/>
               </a:gs>
             </a:gsLst>
             <a:lin ang="18900000" scaled="1"/>
@@ -5316,7 +5292,7 @@
             </a:avLst>
           </a:prstGeom>
           <a:solidFill>
-            <a:srgbClr val="8DC63F"/>
+            <a:srgbClr val="C5A86F"/>
           </a:solidFill>
           <a:ln>
             <a:noFill/>
@@ -5346,7 +5322,7 @@
             <a:r>
               <a:rPr lang="en-US" altLang="ko-KR" dirty="0">
                 <a:solidFill>
-                  <a:srgbClr val="072B61"/>
+                  <a:srgbClr val="FFFFFF"/>
                 </a:solidFill>
                 <a:latin typeface="Arial" panose="020B0604020202020204" pitchFamily="34" charset="0"/>
                 <a:cs typeface="Arial" panose="020B0604020202020204" pitchFamily="34" charset="0"/>
@@ -5415,7 +5391,7 @@
             <a:avLst/>
           </a:prstGeom>
           <a:solidFill>
-            <a:srgbClr val="072B61"/>
+            <a:srgbClr val="0F0F70"/>
           </a:solidFill>
           <a:ln>
             <a:noFill/>
@@ -5488,7 +5464,7 @@
           </a:solidFill>
           <a:ln w="28575">
             <a:solidFill>
-              <a:srgbClr val="072B61"/>
+              <a:srgbClr val="0F0F70"/>
             </a:solidFill>
           </a:ln>
         </p:spPr>
@@ -5547,7 +5523,7 @@
             <a:r>
               <a:rPr sz="2000" b="1">
                 <a:solidFill>
-                  <a:srgbClr val="072B61"/>
+                  <a:srgbClr val="0F0F70"/>
                 </a:solidFill>
                 <a:latin typeface="Arial"/>
                 <a:ea typeface="Malgun Gothic"/>
@@ -5570,7 +5546,7 @@
             <a:r>
               <a:rPr b="1" sz="1700">
                 <a:solidFill>
-                  <a:srgbClr val="124633"/>
+                  <a:srgbClr val="840032"/>
                 </a:solidFill>
                 <a:latin typeface="Arial"/>
                 <a:ea typeface="Malgun Gothic"/>
@@ -5590,7 +5566,7 @@
             <a:r>
               <a:rPr b="1" sz="1700">
                 <a:solidFill>
-                  <a:srgbClr val="072B61"/>
+                  <a:srgbClr val="0F0F70"/>
                 </a:solidFill>
                 <a:latin typeface="Arial"/>
                 <a:ea typeface="Malgun Gothic"/>
@@ -5631,7 +5607,7 @@
           </a:solidFill>
           <a:ln w="28575">
             <a:solidFill>
-              <a:srgbClr val="8DC63F"/>
+              <a:srgbClr val="C5A86F"/>
             </a:solidFill>
           </a:ln>
         </p:spPr>
@@ -5690,7 +5666,7 @@
             <a:r>
               <a:rPr sz="2000" b="1">
                 <a:solidFill>
-                  <a:srgbClr val="124633"/>
+                  <a:srgbClr val="840032"/>
                 </a:solidFill>
                 <a:latin typeface="Arial"/>
                 <a:ea typeface="Malgun Gothic"/>
@@ -5713,7 +5689,7 @@
             <a:r>
               <a:rPr b="1" sz="1700">
                 <a:solidFill>
-                  <a:srgbClr val="124633"/>
+                  <a:srgbClr val="840032"/>
                 </a:solidFill>
                 <a:latin typeface="Arial"/>
                 <a:ea typeface="Malgun Gothic"/>
@@ -5759,7 +5735,7 @@
             <a:r>
               <a:rPr sz="2800" b="1">
                 <a:solidFill>
-                  <a:srgbClr val="072B61"/>
+                  <a:srgbClr val="0F0F70"/>
                 </a:solidFill>
                 <a:latin typeface="Arial"/>
                 <a:ea typeface="Malgun Gothic"/>
@@ -5795,7 +5771,7 @@
             <a:r>
               <a:rPr sz="1400" b="0">
                 <a:solidFill>
-                  <a:srgbClr val="7C7C7C"/>
+                  <a:srgbClr val="697A82"/>
                 </a:solidFill>
                 <a:latin typeface="Arial"/>
                 <a:ea typeface="Malgun Gothic"/>
@@ -5831,7 +5807,7 @@
             <a:r>
               <a:rPr sz="2800" b="1">
                 <a:solidFill>
-                  <a:srgbClr val="072B61"/>
+                  <a:srgbClr val="0F0F70"/>
                 </a:solidFill>
                 <a:latin typeface="Arial"/>
                 <a:ea typeface="Malgun Gothic"/>
@@ -5867,7 +5843,7 @@
             <a:r>
               <a:rPr sz="1400" b="0">
                 <a:solidFill>
-                  <a:srgbClr val="7C7C7C"/>
+                  <a:srgbClr val="697A82"/>
                 </a:solidFill>
                 <a:latin typeface="Arial"/>
                 <a:ea typeface="Malgun Gothic"/>
@@ -5902,7 +5878,7 @@
             <a:r>
               <a:rPr sz="1400" i="1">
                 <a:solidFill>
-                  <a:srgbClr val="7C7C7C"/>
+                  <a:srgbClr val="697A82"/>
                 </a:solidFill>
                 <a:latin typeface="Arial"/>
                 <a:ea typeface="Malgun Gothic"/>
@@ -5912,7 +5888,7 @@
             <a:r>
               <a:rPr b="1" sz="1400" i="1">
                 <a:solidFill>
-                  <a:srgbClr val="FF6C0F"/>
+                  <a:srgbClr val="840032"/>
                 </a:solidFill>
                 <a:latin typeface="Arial"/>
                 <a:ea typeface="Malgun Gothic"/>
@@ -5922,7 +5898,7 @@
             <a:r>
               <a:rPr sz="1400" i="1">
                 <a:solidFill>
-                  <a:srgbClr val="7C7C7C"/>
+                  <a:srgbClr val="697A82"/>
                 </a:solidFill>
                 <a:latin typeface="Arial"/>
                 <a:ea typeface="Malgun Gothic"/>
@@ -5967,12 +5943,12 @@
           <a:gradFill>
             <a:gsLst>
               <a:gs pos="0">
-                <a:srgbClr val="E8EFE1">
+                <a:srgbClr val="E9E9F2">
                   <a:alpha val="100000"/>
                 </a:srgbClr>
               </a:gs>
               <a:gs pos="60000">
-                <a:srgbClr val="E8EFE1">
+                <a:srgbClr val="E9E9F2">
                   <a:alpha val="35000"/>
                 </a:srgbClr>
               </a:gs>
@@ -6028,10 +6004,10 @@
           <a:gradFill flip="none" rotWithShape="1">
             <a:gsLst>
               <a:gs pos="11000">
-                <a:srgbClr val="04193D"/>
+                <a:srgbClr val="060634"/>
               </a:gs>
               <a:gs pos="56000">
-                <a:srgbClr val="072B61"/>
+                <a:srgbClr val="0F0F70"/>
               </a:gs>
             </a:gsLst>
             <a:lin ang="18900000" scaled="1"/>
@@ -6207,7 +6183,7 @@
             </a:avLst>
           </a:prstGeom>
           <a:solidFill>
-            <a:srgbClr val="8DC63F"/>
+            <a:srgbClr val="C5A86F"/>
           </a:solidFill>
           <a:ln>
             <a:noFill/>
@@ -6237,7 +6213,7 @@
             <a:r>
               <a:rPr lang="en-US" altLang="ko-KR" dirty="0">
                 <a:solidFill>
-                  <a:srgbClr val="072B61"/>
+                  <a:srgbClr val="FFFFFF"/>
                 </a:solidFill>
                 <a:latin typeface="Arial" panose="020B0604020202020204" pitchFamily="34" charset="0"/>
                 <a:cs typeface="Arial" panose="020B0604020202020204" pitchFamily="34" charset="0"/>
@@ -6312,7 +6288,7 @@
           </a:solidFill>
           <a:ln w="28575">
             <a:solidFill>
-              <a:srgbClr val="072B61"/>
+              <a:srgbClr val="0F0F70"/>
             </a:solidFill>
           </a:ln>
         </p:spPr>
@@ -6371,7 +6347,7 @@
             <a:r>
               <a:rPr sz="2000" b="1">
                 <a:solidFill>
-                  <a:srgbClr val="072B61"/>
+                  <a:srgbClr val="0F0F70"/>
                 </a:solidFill>
                 <a:latin typeface="Arial"/>
                 <a:ea typeface="Malgun Gothic"/>
@@ -6394,7 +6370,7 @@
             <a:r>
               <a:rPr b="1" sz="1700">
                 <a:solidFill>
-                  <a:srgbClr val="124633"/>
+                  <a:srgbClr val="840032"/>
                 </a:solidFill>
                 <a:latin typeface="Arial"/>
                 <a:ea typeface="Malgun Gothic"/>
@@ -6435,7 +6411,7 @@
           </a:solidFill>
           <a:ln w="28575">
             <a:solidFill>
-              <a:srgbClr val="8DC63F"/>
+              <a:srgbClr val="C5A86F"/>
             </a:solidFill>
           </a:ln>
         </p:spPr>
@@ -6494,7 +6470,7 @@
             <a:r>
               <a:rPr sz="2000" b="1">
                 <a:solidFill>
-                  <a:srgbClr val="124633"/>
+                  <a:srgbClr val="840032"/>
                 </a:solidFill>
                 <a:latin typeface="Arial"/>
                 <a:ea typeface="Malgun Gothic"/>
@@ -6517,7 +6493,7 @@
             <a:r>
               <a:rPr b="1" sz="1700">
                 <a:solidFill>
-                  <a:srgbClr val="124633"/>
+                  <a:srgbClr val="840032"/>
                 </a:solidFill>
                 <a:latin typeface="Arial"/>
                 <a:ea typeface="Malgun Gothic"/>
@@ -6558,7 +6534,7 @@
           </a:solidFill>
           <a:ln w="28575">
             <a:solidFill>
-              <a:srgbClr val="072B61"/>
+              <a:srgbClr val="0F0F70"/>
             </a:solidFill>
           </a:ln>
         </p:spPr>
@@ -6617,7 +6593,7 @@
             <a:r>
               <a:rPr sz="2000" b="1">
                 <a:solidFill>
-                  <a:srgbClr val="072B61"/>
+                  <a:srgbClr val="0F0F70"/>
                 </a:solidFill>
                 <a:latin typeface="Arial"/>
                 <a:ea typeface="Malgun Gothic"/>
@@ -6640,7 +6616,7 @@
             <a:r>
               <a:rPr b="1" sz="1700">
                 <a:solidFill>
-                  <a:srgbClr val="124633"/>
+                  <a:srgbClr val="840032"/>
                 </a:solidFill>
                 <a:latin typeface="Arial"/>
                 <a:ea typeface="Malgun Gothic"/>
@@ -6685,7 +6661,7 @@
             <a:r>
               <a:rPr sz="1400" i="1">
                 <a:solidFill>
-                  <a:srgbClr val="7C7C7C"/>
+                  <a:srgbClr val="697A82"/>
                 </a:solidFill>
                 <a:latin typeface="Arial"/>
                 <a:ea typeface="Malgun Gothic"/>
@@ -6695,7 +6671,7 @@
             <a:r>
               <a:rPr b="1" sz="1400" i="1">
                 <a:solidFill>
-                  <a:srgbClr val="FF6C0F"/>
+                  <a:srgbClr val="840032"/>
                 </a:solidFill>
                 <a:latin typeface="Arial"/>
                 <a:ea typeface="Malgun Gothic"/>
@@ -6705,7 +6681,7 @@
             <a:r>
               <a:rPr sz="1400" i="1">
                 <a:solidFill>
-                  <a:srgbClr val="7C7C7C"/>
+                  <a:srgbClr val="697A82"/>
                 </a:solidFill>
                 <a:latin typeface="Arial"/>
                 <a:ea typeface="Malgun Gothic"/>
@@ -6748,7 +6724,7 @@
             <a:avLst/>
           </a:prstGeom>
           <a:solidFill>
-            <a:srgbClr val="072B61"/>
+            <a:srgbClr val="0F0F70"/>
           </a:solidFill>
           <a:ln>
             <a:noFill/>

</xml_diff>

<commit_message>
benchmark: English copy + red inline emphasis + lighter banner tint
- translate the catalysis benchmark deck to English
- snu theme: body stays black, inline emphasis (**bold**/*em*) unified to red
  #C00000; card heads/banner/number-block/pill stay navy/gold
- generate.py + export_pptx: bold uses new bold_color token (fallback navy)
- snu banner gradient: lighter navy tint / higher white opacity (less washed-out)
</commit_message>
<xml_diff>
--- a/samples/benchmark_catalysis_deck.pptx
+++ b/samples/benchmark_catalysis_deck.pptx
@@ -3212,7 +3212,7 @@
                 <a:latin typeface="Arial"/>
                 <a:ea typeface="Malgun Gothic"/>
               </a:rPr>
-              <a:t>계산화학을 통한 촉매 연구</a:t>
+              <a:t>Computational Chemistry for Catalysis</a:t>
             </a:r>
           </a:p>
         </p:txBody>
@@ -3292,7 +3292,7 @@
                 <a:latin typeface="Arial"/>
                 <a:ea typeface="Malgun Gothic"/>
               </a:rPr>
-              <a:t>DFT · 머신러닝 퍼텐셜 · 디스크립터를 통합한 다중스케일 촉매 설계</a:t>
+              <a:t>Multiscale catalyst design integrating DFT, machine-learning potentials, and descriptors</a:t>
             </a:r>
           </a:p>
         </p:txBody>
@@ -3372,7 +3372,7 @@
                 <a:latin typeface="Arial"/>
                 <a:ea typeface="Malgun Gothic"/>
               </a:rPr>
-              <a:t>정석현 (Seokhyun Choung)</a:t>
+              <a:t>Seokhyun Choung</a:t>
             </a:r>
           </a:p>
         </p:txBody>
@@ -3408,7 +3408,7 @@
                 <a:latin typeface="Arial"/>
                 <a:ea typeface="Malgun Gothic"/>
               </a:rPr>
-              <a:t>2026. 06. 04.</a:t>
+              <a:t>June 4, 2026</a:t>
             </a:r>
           </a:p>
         </p:txBody>
@@ -3762,7 +3762,7 @@
                 <a:ea typeface="Malgun Gothic" panose="020B0600000101010101" pitchFamily="50" charset="-127"/>
                 <a:cs typeface="Arial" panose="020B0604020202020204" pitchFamily="34" charset="0"/>
               </a:rPr>
-              <a:t>왜 계산화학으로 촉매를 보는가</a:t>
+              <a:t>Why Study Catalysis Computationally</a:t>
             </a:r>
             <a:endParaRPr kumimoji="1" lang="ko-KR" altLang="en-US" sz="2400" dirty="0">
               <a:latin typeface="Arial" panose="020B0604020202020204" pitchFamily="34" charset="0"/>
@@ -3781,7 +3781,7 @@
         <p:spPr>
           <a:xfrm>
             <a:off x="400050" y="1066800"/>
-            <a:ext cx="3248025" cy="381000"/>
+            <a:ext cx="6324600" cy="381000"/>
           </a:xfrm>
           <a:prstGeom prst="roundRect">
             <a:avLst/>
@@ -3834,7 +3834,7 @@
                 <a:cs typeface="Arial" panose="020B0604020202020204" pitchFamily="34" charset="0"/>
                 <a:ea typeface="Malgun Gothic"/>
               </a:rPr>
-              <a:t>실험만으로는 닿지 않는 영역</a:t>
+              <a:t>Reaching what experiments cannot</a:t>
             </a:r>
           </a:p>
         </p:txBody>
@@ -3884,17 +3884,17 @@
                 <a:latin typeface="Arial"/>
                 <a:ea typeface="Malgun Gothic"/>
               </a:rPr>
-              <a:t>반응 중간체의 </a:t>
+              <a:t>Reaction intermediates live for only </a:t>
             </a:r>
             <a:r>
               <a:rPr b="1" sz="1700">
                 <a:solidFill>
-                  <a:srgbClr val="0F0F70"/>
-                </a:solidFill>
-                <a:latin typeface="Arial"/>
-                <a:ea typeface="Malgun Gothic"/>
-              </a:rPr>
-              <a:t>수명이 ps~ns</a:t>
+                  <a:srgbClr val="C00000"/>
+                </a:solidFill>
+                <a:latin typeface="Arial"/>
+                <a:ea typeface="Malgun Gothic"/>
+              </a:rPr>
+              <a:t>ps–ns</a:t>
             </a:r>
             <a:r>
               <a:rPr sz="1700" b="0">
@@ -3904,27 +3904,17 @@
                 <a:latin typeface="Arial"/>
                 <a:ea typeface="Malgun Gothic"/>
               </a:rPr>
-              <a:t> 수준이라 in-situ 관측이 어려움 — 계산은 </a:t>
+              <a:t>, so in-situ observation is hard — computation delivers </a:t>
             </a:r>
             <a:r>
               <a:rPr b="1" sz="1700">
                 <a:solidFill>
-                  <a:srgbClr val="840032"/>
-                </a:solidFill>
-                <a:latin typeface="Arial"/>
-                <a:ea typeface="Malgun Gothic"/>
-              </a:rPr>
-              <a:t>원자 단위 스냅샷</a:t>
-            </a:r>
-            <a:r>
-              <a:rPr sz="1700" b="0">
-                <a:solidFill>
-                  <a:srgbClr val="1A1A1A"/>
-                </a:solidFill>
-                <a:latin typeface="Arial"/>
-                <a:ea typeface="Malgun Gothic"/>
-              </a:rPr>
-              <a:t>을 제공</a:t>
+                  <a:srgbClr val="C00000"/>
+                </a:solidFill>
+                <a:latin typeface="Arial"/>
+                <a:ea typeface="Malgun Gothic"/>
+              </a:rPr>
+              <a:t>atomic-scale snapshots</a:t>
             </a:r>
           </a:p>
           <a:p>
@@ -3951,17 +3941,17 @@
                 <a:latin typeface="Arial"/>
                 <a:ea typeface="Malgun Gothic"/>
               </a:rPr>
-              <a:t>활성점 후보가 </a:t>
+              <a:t>Active-site candidates explode to </a:t>
             </a:r>
             <a:r>
               <a:rPr b="1" sz="1700">
                 <a:solidFill>
-                  <a:srgbClr val="0F0F70"/>
-                </a:solidFill>
-                <a:latin typeface="Arial"/>
-                <a:ea typeface="Malgun Gothic"/>
-              </a:rPr>
-              <a:t>10⁴~10⁶ 조합</a:t>
+                  <a:srgbClr val="C00000"/>
+                </a:solidFill>
+                <a:latin typeface="Arial"/>
+                <a:ea typeface="Malgun Gothic"/>
+              </a:rPr>
+              <a:t>10⁴–10⁶</a:t>
             </a:r>
             <a:r>
               <a:rPr sz="1700" b="0">
@@ -3971,7 +3961,7 @@
                 <a:latin typeface="Arial"/>
                 <a:ea typeface="Malgun Gothic"/>
               </a:rPr>
-              <a:t>으로 폭발 — 실험 스크리닝은 비용·시간이 비현실적</a:t>
+              <a:t> combinations — purely experimental screening is too costly and slow</a:t>
             </a:r>
           </a:p>
           <a:p>
@@ -3991,14 +3981,24 @@
               <a:t>✓  </a:t>
             </a:r>
             <a:r>
+              <a:rPr sz="1700" b="0">
+                <a:solidFill>
+                  <a:srgbClr val="1A1A1A"/>
+                </a:solidFill>
+                <a:latin typeface="Arial"/>
+                <a:ea typeface="Malgun Gothic"/>
+              </a:rPr>
+              <a:t>Trace activity and selectivity back to their </a:t>
+            </a:r>
+            <a:r>
               <a:rPr b="1" sz="1700">
                 <a:solidFill>
-                  <a:srgbClr val="840032"/>
-                </a:solidFill>
-                <a:latin typeface="Arial"/>
-                <a:ea typeface="Malgun Gothic"/>
-              </a:rPr>
-              <a:t>전자구조</a:t>
+                  <a:srgbClr val="C00000"/>
+                </a:solidFill>
+                <a:latin typeface="Arial"/>
+                <a:ea typeface="Malgun Gothic"/>
+              </a:rPr>
+              <a:t>electronic-structure</a:t>
             </a:r>
             <a:r>
               <a:rPr sz="1700" b="0">
@@ -4008,27 +4008,17 @@
                 <a:latin typeface="Arial"/>
                 <a:ea typeface="Malgun Gothic"/>
               </a:rPr>
-              <a:t>에서 활성·선택성의 기원을 직접 추적해 </a:t>
+              <a:t> origin, distilling them into </a:t>
             </a:r>
             <a:r>
               <a:rPr b="1" sz="1700">
                 <a:solidFill>
-                  <a:srgbClr val="0F0F70"/>
-                </a:solidFill>
-                <a:latin typeface="Arial"/>
-                <a:ea typeface="Malgun Gothic"/>
-              </a:rPr>
-              <a:t>설계 원리</a:t>
-            </a:r>
-            <a:r>
-              <a:rPr sz="1700" b="0">
-                <a:solidFill>
-                  <a:srgbClr val="1A1A1A"/>
-                </a:solidFill>
-                <a:latin typeface="Arial"/>
-                <a:ea typeface="Malgun Gothic"/>
-              </a:rPr>
-              <a:t>로 환원</a:t>
+                  <a:srgbClr val="C00000"/>
+                </a:solidFill>
+                <a:latin typeface="Arial"/>
+                <a:ea typeface="Malgun Gothic"/>
+              </a:rPr>
+              <a:t>design principles</a:t>
             </a:r>
           </a:p>
         </p:txBody>
@@ -4042,7 +4032,7 @@
         <p:spPr>
           <a:xfrm>
             <a:off x="400050" y="2847975"/>
-            <a:ext cx="11391900" cy="381000"/>
+            <a:ext cx="11391900" cy="704850"/>
           </a:xfrm>
           <a:prstGeom prst="rect">
             <a:avLst/>
@@ -4064,17 +4054,17 @@
                 <a:latin typeface="Arial"/>
                 <a:ea typeface="Malgun Gothic"/>
               </a:rPr>
-              <a:t>→ 계산화학은 </a:t>
+              <a:t>→ Computation accelerates </a:t>
             </a:r>
             <a:r>
               <a:rPr b="1" sz="1700">
                 <a:solidFill>
-                  <a:srgbClr val="840032"/>
-                </a:solidFill>
-                <a:latin typeface="Arial"/>
-                <a:ea typeface="Malgun Gothic"/>
-              </a:rPr>
-              <a:t>가설 생성</a:t>
+                  <a:srgbClr val="C00000"/>
+                </a:solidFill>
+                <a:latin typeface="Arial"/>
+                <a:ea typeface="Malgun Gothic"/>
+              </a:rPr>
+              <a:t>hypothesis generation</a:t>
             </a:r>
             <a:r>
               <a:rPr sz="1700" b="0">
@@ -4084,17 +4074,17 @@
                 <a:latin typeface="Arial"/>
                 <a:ea typeface="Malgun Gothic"/>
               </a:rPr>
-              <a:t>과 </a:t>
+              <a:t> and </a:t>
             </a:r>
             <a:r>
               <a:rPr b="1" sz="1700">
                 <a:solidFill>
-                  <a:srgbClr val="840032"/>
-                </a:solidFill>
-                <a:latin typeface="Arial"/>
-                <a:ea typeface="Malgun Gothic"/>
-              </a:rPr>
-              <a:t>후보 선별</a:t>
+                  <a:srgbClr val="C00000"/>
+                </a:solidFill>
+                <a:latin typeface="Arial"/>
+                <a:ea typeface="Malgun Gothic"/>
+              </a:rPr>
+              <a:t>candidate selection</a:t>
             </a:r>
             <a:r>
               <a:rPr sz="1700" b="0">
@@ -4104,17 +4094,17 @@
                 <a:latin typeface="Arial"/>
                 <a:ea typeface="Malgun Gothic"/>
               </a:rPr>
-              <a:t>을 가속하고, 실험은 검증에 집중하는 </a:t>
+              <a:t>, letting experiments focus on validation — a </a:t>
             </a:r>
             <a:r>
               <a:rPr b="1" sz="1700">
                 <a:solidFill>
-                  <a:srgbClr val="0F0F70"/>
-                </a:solidFill>
-                <a:latin typeface="Arial"/>
-                <a:ea typeface="Malgun Gothic"/>
-              </a:rPr>
-              <a:t>closed-loop</a:t>
+                  <a:srgbClr val="C00000"/>
+                </a:solidFill>
+                <a:latin typeface="Arial"/>
+                <a:ea typeface="Malgun Gothic"/>
+              </a:rPr>
+              <a:t>closed loop</a:t>
             </a:r>
             <a:r>
               <a:rPr sz="1700" b="0">
@@ -4124,7 +4114,7 @@
                 <a:latin typeface="Arial"/>
                 <a:ea typeface="Malgun Gothic"/>
               </a:rPr>
-              <a:t>를 만든다.</a:t>
+              <a:t>.</a:t>
             </a:r>
           </a:p>
         </p:txBody>
@@ -4159,17 +4149,17 @@
                 <a:latin typeface="Arial"/>
                 <a:ea typeface="Malgun Gothic"/>
               </a:rPr>
-              <a:t>핵심: 계산은 실험을 대체하지 않고 </a:t>
+              <a:t>Key idea: computation does not replace experiment — it </a:t>
             </a:r>
             <a:r>
               <a:rPr b="1" sz="1400" i="1">
                 <a:solidFill>
-                  <a:srgbClr val="840032"/>
-                </a:solidFill>
-                <a:latin typeface="Arial"/>
-                <a:ea typeface="Malgun Gothic"/>
-              </a:rPr>
-              <a:t>탐색 공간을 좁힌다</a:t>
+                  <a:srgbClr val="C00000"/>
+                </a:solidFill>
+                <a:latin typeface="Arial"/>
+                <a:ea typeface="Malgun Gothic"/>
+              </a:rPr>
+              <a:t>narrows the search space</a:t>
             </a:r>
           </a:p>
         </p:txBody>
@@ -4523,7 +4513,7 @@
                 <a:ea typeface="Malgun Gothic" panose="020B0600000101010101" pitchFamily="50" charset="-127"/>
                 <a:cs typeface="Arial" panose="020B0604020202020204" pitchFamily="34" charset="0"/>
               </a:rPr>
-              <a:t>다중스케일 계산 스택</a:t>
+              <a:t>A Multiscale Computational Stack</a:t>
             </a:r>
             <a:endParaRPr kumimoji="1" lang="ko-KR" altLang="en-US" sz="2400" dirty="0">
               <a:latin typeface="Arial" panose="020B0604020202020204" pitchFamily="34" charset="0"/>
@@ -4631,17 +4621,17 @@
                 <a:latin typeface="Arial"/>
                 <a:ea typeface="Malgun Gothic"/>
               </a:rPr>
-              <a:t>흡착에너지·전이상태·d-band center를 </a:t>
+              <a:t>Adsorption energies, transition states, and the d-band center from </a:t>
             </a:r>
             <a:r>
               <a:rPr b="1" sz="1700">
                 <a:solidFill>
-                  <a:srgbClr val="840032"/>
-                </a:solidFill>
-                <a:latin typeface="Arial"/>
-                <a:ea typeface="Malgun Gothic"/>
-              </a:rPr>
-              <a:t>제일원리</a:t>
+                  <a:srgbClr val="C00000"/>
+                </a:solidFill>
+                <a:latin typeface="Arial"/>
+                <a:ea typeface="Malgun Gothic"/>
+              </a:rPr>
+              <a:t>first principles</a:t>
             </a:r>
             <a:r>
               <a:rPr sz="1700" b="0">
@@ -4651,17 +4641,17 @@
                 <a:latin typeface="Arial"/>
                 <a:ea typeface="Malgun Gothic"/>
               </a:rPr>
-              <a:t>로 계산. 정확도 기준점(ground truth)을 제공하지만 </a:t>
+              <a:t>. The accuracy benchmark (ground truth), but it stalls at the </a:t>
             </a:r>
             <a:r>
               <a:rPr b="1" sz="1700">
                 <a:solidFill>
-                  <a:srgbClr val="840032"/>
-                </a:solidFill>
-                <a:latin typeface="Arial"/>
-                <a:ea typeface="Malgun Gothic"/>
-              </a:rPr>
-              <a:t>수백 원자</a:t>
+                  <a:srgbClr val="C00000"/>
+                </a:solidFill>
+                <a:latin typeface="Arial"/>
+                <a:ea typeface="Malgun Gothic"/>
+              </a:rPr>
+              <a:t>few-hundred-atom</a:t>
             </a:r>
             <a:r>
               <a:rPr sz="1700" b="0">
@@ -4671,7 +4661,7 @@
                 <a:latin typeface="Arial"/>
                 <a:ea typeface="Malgun Gothic"/>
               </a:rPr>
-              <a:t> 규모에서 멈춤.</a:t>
+              <a:t> scale.</a:t>
             </a:r>
           </a:p>
         </p:txBody>
@@ -4697,7 +4687,7 @@
           </a:solidFill>
           <a:ln w="28575">
             <a:solidFill>
-              <a:srgbClr val="C5A86F"/>
+              <a:srgbClr val="0F0F70"/>
             </a:solidFill>
           </a:ln>
         </p:spPr>
@@ -4722,7 +4712,7 @@
           <a:lstStyle/>
           <a:p>
             <a:pPr algn="ctr" latinLnBrk="0"/>
-            <a:endParaRPr lang="ko-KR" altLang="en-US" dirty="0">
+            <a:endParaRPr lang="ko-KR" altLang="en-US" b="1" dirty="0">
               <a:latin typeface="Arial" panose="020B0604020202020204" pitchFamily="34" charset="0"/>
               <a:ea typeface="맑은 고딕" panose="020B0600000101010101" pitchFamily="50" charset="-127"/>
               <a:cs typeface="Arial" panose="020B0604020202020204" pitchFamily="34" charset="0"/>
@@ -4756,17 +4746,27 @@
             <a:r>
               <a:rPr sz="2000" b="1">
                 <a:solidFill>
-                  <a:srgbClr val="840032"/>
-                </a:solidFill>
-                <a:latin typeface="Arial"/>
-                <a:ea typeface="Malgun Gothic"/>
-              </a:rPr>
-              <a:t>ML 퍼텐셜</a:t>
+                  <a:srgbClr val="0F0F70"/>
+                </a:solidFill>
+                <a:latin typeface="Arial"/>
+                <a:ea typeface="Malgun Gothic"/>
+              </a:rPr>
+              <a:t>ML Potentials</a:t>
             </a:r>
           </a:p>
           <a:p>
             <a:pPr algn="l"/>
             <a:r>
+              <a:rPr b="1" sz="1700">
+                <a:solidFill>
+                  <a:srgbClr val="C00000"/>
+                </a:solidFill>
+                <a:latin typeface="Arial"/>
+                <a:ea typeface="Malgun Gothic"/>
+              </a:rPr>
+              <a:t>MLIPs</a:t>
+            </a:r>
+            <a:r>
               <a:rPr sz="1700" b="0">
                 <a:solidFill>
                   <a:srgbClr val="1A1A1A"/>
@@ -4774,17 +4774,17 @@
                 <a:latin typeface="Arial"/>
                 <a:ea typeface="Malgun Gothic"/>
               </a:rPr>
-              <a:t>DFT 데이터로 학습한 </a:t>
+              <a:t> (NequIP, MACE) trained on DFT give </a:t>
             </a:r>
             <a:r>
               <a:rPr b="1" sz="1700">
                 <a:solidFill>
-                  <a:srgbClr val="0F0F70"/>
-                </a:solidFill>
-                <a:latin typeface="Arial"/>
-                <a:ea typeface="Malgun Gothic"/>
-              </a:rPr>
-              <a:t>MLIP</a:t>
+                  <a:srgbClr val="C00000"/>
+                </a:solidFill>
+                <a:latin typeface="Arial"/>
+                <a:ea typeface="Malgun Gothic"/>
+              </a:rPr>
+              <a:t>DFT accuracy at MD speed</a:t>
             </a:r>
             <a:r>
               <a:rPr sz="1700" b="0">
@@ -4794,27 +4794,7 @@
                 <a:latin typeface="Arial"/>
                 <a:ea typeface="Malgun Gothic"/>
               </a:rPr>
-              <a:t>(NequIP·MACE)로 </a:t>
-            </a:r>
-            <a:r>
-              <a:rPr b="1" sz="1700">
-                <a:solidFill>
-                  <a:srgbClr val="840032"/>
-                </a:solidFill>
-                <a:latin typeface="Arial"/>
-                <a:ea typeface="Malgun Gothic"/>
-              </a:rPr>
-              <a:t>DFT 정확도 × MD 속도</a:t>
-            </a:r>
-            <a:r>
-              <a:rPr sz="1700" b="0">
-                <a:solidFill>
-                  <a:srgbClr val="1A1A1A"/>
-                </a:solidFill>
-                <a:latin typeface="Arial"/>
-                <a:ea typeface="Malgun Gothic"/>
-              </a:rPr>
-              <a:t>. 나노입자·동역학·앙상블 샘플링까지 확장.</a:t>
+              <a:t> — extending to nanoparticles, dynamics, and ensemble sampling.</a:t>
             </a:r>
           </a:p>
         </p:txBody>
@@ -4917,17 +4897,17 @@
                 <a:latin typeface="Arial"/>
                 <a:ea typeface="Malgun Gothic"/>
               </a:rPr>
-              <a:t>계산된 에너지를 </a:t>
+              <a:t>Feed computed energies into </a:t>
             </a:r>
             <a:r>
               <a:rPr b="1" sz="1700">
                 <a:solidFill>
-                  <a:srgbClr val="0F0F70"/>
-                </a:solidFill>
-                <a:latin typeface="Arial"/>
-                <a:ea typeface="Malgun Gothic"/>
-              </a:rPr>
-              <a:t>반응속도식</a:t>
+                  <a:srgbClr val="C00000"/>
+                </a:solidFill>
+                <a:latin typeface="Arial"/>
+                <a:ea typeface="Malgun Gothic"/>
+              </a:rPr>
+              <a:t>rate equations</a:t>
             </a:r>
             <a:r>
               <a:rPr sz="1700" b="0">
@@ -4937,12 +4917,12 @@
                 <a:latin typeface="Arial"/>
                 <a:ea typeface="Malgun Gothic"/>
               </a:rPr>
-              <a:t>에 넣어 </a:t>
+              <a:t> to compare </a:t>
             </a:r>
             <a:r>
               <a:rPr b="1" sz="1700">
                 <a:solidFill>
-                  <a:srgbClr val="840032"/>
+                  <a:srgbClr val="C00000"/>
                 </a:solidFill>
                 <a:latin typeface="Arial"/>
                 <a:ea typeface="Malgun Gothic"/>
@@ -4957,7 +4937,7 @@
                 <a:latin typeface="Arial"/>
                 <a:ea typeface="Malgun Gothic"/>
               </a:rPr>
-              <a:t>·rate-determining step·반응차수를 실험과 직접 비교.</a:t>
+              <a:t>, the rate-determining step, and reaction orders directly with experiment.</a:t>
             </a:r>
           </a:p>
         </p:txBody>
@@ -4992,17 +4972,17 @@
                 <a:latin typeface="Arial"/>
                 <a:ea typeface="Malgun Gothic"/>
               </a:rPr>
-              <a:t>원자 → 나노입자 → 반응기 조건까지 </a:t>
+              <a:t>A pipeline that </a:t>
             </a:r>
             <a:r>
               <a:rPr b="1" sz="1400" i="1">
                 <a:solidFill>
-                  <a:srgbClr val="840032"/>
-                </a:solidFill>
-                <a:latin typeface="Arial"/>
-                <a:ea typeface="Malgun Gothic"/>
-              </a:rPr>
-              <a:t>스케일을 잇는</a:t>
+                  <a:srgbClr val="C00000"/>
+                </a:solidFill>
+                <a:latin typeface="Arial"/>
+                <a:ea typeface="Malgun Gothic"/>
+              </a:rPr>
+              <a:t>bridges scales</a:t>
             </a:r>
             <a:r>
               <a:rPr sz="1400" i="1">
@@ -5012,7 +4992,7 @@
                 <a:latin typeface="Arial"/>
                 <a:ea typeface="Malgun Gothic"/>
               </a:rPr>
-              <a:t> 파이프라인</a:t>
+              <a:t> — from atoms to nanoparticles to reactor conditions</a:t>
             </a:r>
           </a:p>
         </p:txBody>
@@ -5366,7 +5346,7 @@
                 <a:ea typeface="Malgun Gothic" panose="020B0600000101010101" pitchFamily="50" charset="-127"/>
                 <a:cs typeface="Arial" panose="020B0604020202020204" pitchFamily="34" charset="0"/>
               </a:rPr>
-              <a:t>디스크립터와 스케일링 관계</a:t>
+              <a:t>Descriptors and Scaling Relations</a:t>
             </a:r>
             <a:endParaRPr kumimoji="1" lang="ko-KR" altLang="en-US" sz="2400" dirty="0">
               <a:latin typeface="Arial" panose="020B0604020202020204" pitchFamily="34" charset="0"/>
@@ -5385,7 +5365,7 @@
         <p:spPr>
           <a:xfrm>
             <a:off x="400050" y="1066800"/>
-            <a:ext cx="3971925" cy="381000"/>
+            <a:ext cx="9401175" cy="381000"/>
           </a:xfrm>
           <a:prstGeom prst="roundRect">
             <a:avLst/>
@@ -5438,7 +5418,7 @@
                 <a:cs typeface="Arial" panose="020B0604020202020204" pitchFamily="34" charset="0"/>
                 <a:ea typeface="Malgun Gothic"/>
               </a:rPr>
-              <a:t>복잡한 활성을 몇 개의 변수로 압축</a:t>
+              <a:t>Compressing complex activity into a few variables</a:t>
             </a:r>
           </a:p>
         </p:txBody>
@@ -5528,7 +5508,7 @@
                 <a:latin typeface="Arial"/>
                 <a:ea typeface="Malgun Gothic"/>
               </a:rPr>
-              <a:t>스케일링 관계</a:t>
+              <a:t>Scaling relations</a:t>
             </a:r>
           </a:p>
           <a:p>
@@ -5541,17 +5521,17 @@
                 <a:latin typeface="Arial"/>
                 <a:ea typeface="Malgun Gothic"/>
               </a:rPr>
-              <a:t>흡착종 에너지들이 </a:t>
+              <a:t>Adsorbate energies are </a:t>
             </a:r>
             <a:r>
               <a:rPr b="1" sz="1700">
                 <a:solidFill>
-                  <a:srgbClr val="840032"/>
-                </a:solidFill>
-                <a:latin typeface="Arial"/>
-                <a:ea typeface="Malgun Gothic"/>
-              </a:rPr>
-              <a:t>선형</a:t>
+                  <a:srgbClr val="C00000"/>
+                </a:solidFill>
+                <a:latin typeface="Arial"/>
+                <a:ea typeface="Malgun Gothic"/>
+              </a:rPr>
+              <a:t>linearly</a:t>
             </a:r>
             <a:r>
               <a:rPr sz="1700" b="0">
@@ -5561,17 +5541,17 @@
                 <a:latin typeface="Arial"/>
                 <a:ea typeface="Malgun Gothic"/>
               </a:rPr>
-              <a:t>으로 묶여, </a:t>
+              <a:t> coupled, so a </a:t>
             </a:r>
             <a:r>
               <a:rPr b="1" sz="1700">
                 <a:solidFill>
-                  <a:srgbClr val="0F0F70"/>
-                </a:solidFill>
-                <a:latin typeface="Arial"/>
-                <a:ea typeface="Malgun Gothic"/>
-              </a:rPr>
-              <a:t>단일 디스크립터</a:t>
+                  <a:srgbClr val="C00000"/>
+                </a:solidFill>
+                <a:latin typeface="Arial"/>
+                <a:ea typeface="Malgun Gothic"/>
+              </a:rPr>
+              <a:t>single descriptor</a:t>
             </a:r>
             <a:r>
               <a:rPr sz="1700" b="0">
@@ -5581,7 +5561,7 @@
                 <a:latin typeface="Arial"/>
                 <a:ea typeface="Malgun Gothic"/>
               </a:rPr>
-              <a:t>(예: O 흡착에너지)만으로 활성 예측이 가능하다.</a:t>
+              <a:t> (e.g. O binding energy) can predict activity.</a:t>
             </a:r>
           </a:p>
         </p:txBody>
@@ -5607,7 +5587,7 @@
           </a:solidFill>
           <a:ln w="28575">
             <a:solidFill>
-              <a:srgbClr val="C5A86F"/>
+              <a:srgbClr val="0F0F70"/>
             </a:solidFill>
           </a:ln>
         </p:spPr>
@@ -5632,7 +5612,7 @@
           <a:lstStyle/>
           <a:p>
             <a:pPr algn="ctr" latinLnBrk="0"/>
-            <a:endParaRPr lang="ko-KR" altLang="en-US" dirty="0">
+            <a:endParaRPr lang="ko-KR" altLang="en-US" b="1" dirty="0">
               <a:latin typeface="Arial" panose="020B0604020202020204" pitchFamily="34" charset="0"/>
               <a:ea typeface="맑은 고딕" panose="020B0600000101010101" pitchFamily="50" charset="-127"/>
               <a:cs typeface="Arial" panose="020B0604020202020204" pitchFamily="34" charset="0"/>
@@ -5666,12 +5646,12 @@
             <a:r>
               <a:rPr sz="2000" b="1">
                 <a:solidFill>
-                  <a:srgbClr val="840032"/>
-                </a:solidFill>
-                <a:latin typeface="Arial"/>
-                <a:ea typeface="Malgun Gothic"/>
-              </a:rPr>
-              <a:t>Sabatier 화산형</a:t>
+                  <a:srgbClr val="0F0F70"/>
+                </a:solidFill>
+                <a:latin typeface="Arial"/>
+                <a:ea typeface="Malgun Gothic"/>
+              </a:rPr>
+              <a:t>Sabatier volcano</a:t>
             </a:r>
           </a:p>
           <a:p>
@@ -5684,17 +5664,17 @@
                 <a:latin typeface="Arial"/>
                 <a:ea typeface="Malgun Gothic"/>
               </a:rPr>
-              <a:t>결합이 너무 약하면 활성화 못 하고, 너무 강하면 피독 — </a:t>
+              <a:t>Bind too weakly and nothing activates; bind too strongly and the surface poisons — </a:t>
             </a:r>
             <a:r>
               <a:rPr b="1" sz="1700">
                 <a:solidFill>
-                  <a:srgbClr val="840032"/>
-                </a:solidFill>
-                <a:latin typeface="Arial"/>
-                <a:ea typeface="Malgun Gothic"/>
-              </a:rPr>
-              <a:t>활성에는 최적점</a:t>
+                  <a:srgbClr val="C00000"/>
+                </a:solidFill>
+                <a:latin typeface="Arial"/>
+                <a:ea typeface="Malgun Gothic"/>
+              </a:rPr>
+              <a:t>an optimum exists</a:t>
             </a:r>
             <a:r>
               <a:rPr sz="1700" b="0">
@@ -5704,7 +5684,7 @@
                 <a:latin typeface="Arial"/>
                 <a:ea typeface="Malgun Gothic"/>
               </a:rPr>
-              <a:t>이 존재한다.</a:t>
+              <a:t>.</a:t>
             </a:r>
           </a:p>
         </p:txBody>
@@ -5718,7 +5698,7 @@
         <p:spPr>
           <a:xfrm>
             <a:off x="400050" y="3790950"/>
-            <a:ext cx="1333500" cy="400050"/>
+            <a:ext cx="2800350" cy="400050"/>
           </a:xfrm>
           <a:prstGeom prst="rect">
             <a:avLst/>
@@ -5740,7 +5720,7 @@
                 <a:latin typeface="Arial"/>
                 <a:ea typeface="Malgun Gothic"/>
               </a:rPr>
-              <a:t>1~2</a:t>
+              <a:t>1–2</a:t>
             </a:r>
           </a:p>
         </p:txBody>
@@ -5754,7 +5734,7 @@
         <p:spPr>
           <a:xfrm>
             <a:off x="400050" y="4191000"/>
-            <a:ext cx="1333500" cy="209550"/>
+            <a:ext cx="2800350" cy="209550"/>
           </a:xfrm>
           <a:prstGeom prst="rect">
             <a:avLst/>
@@ -5776,7 +5756,7 @@
                 <a:latin typeface="Arial"/>
                 <a:ea typeface="Malgun Gothic"/>
               </a:rPr>
-              <a:t>지배 디스크립터 수</a:t>
+              <a:t>governing descriptors</a:t>
             </a:r>
           </a:p>
         </p:txBody>
@@ -5789,8 +5769,8 @@
         </p:nvSpPr>
         <p:spPr>
           <a:xfrm>
-            <a:off x="1962150" y="3790950"/>
-            <a:ext cx="1400175" cy="400050"/>
+            <a:off x="3429000" y="3790950"/>
+            <a:ext cx="3067050" cy="400050"/>
           </a:xfrm>
           <a:prstGeom prst="rect">
             <a:avLst/>
@@ -5825,8 +5805,8 @@
         </p:nvSpPr>
         <p:spPr>
           <a:xfrm>
-            <a:off x="1962150" y="4191000"/>
-            <a:ext cx="1400175" cy="209550"/>
+            <a:off x="3429000" y="4191000"/>
+            <a:ext cx="3067050" cy="209550"/>
           </a:xfrm>
           <a:prstGeom prst="rect">
             <a:avLst/>
@@ -5848,7 +5828,7 @@
                 <a:latin typeface="Arial"/>
                 <a:ea typeface="Malgun Gothic"/>
               </a:rPr>
-              <a:t>목표 예측 오차</a:t>
+              <a:t>target prediction error</a:t>
             </a:r>
           </a:p>
         </p:txBody>
@@ -5883,17 +5863,17 @@
                 <a:latin typeface="Arial"/>
                 <a:ea typeface="Malgun Gothic"/>
               </a:rPr>
-              <a:t>스케일링의 </a:t>
+              <a:t>Next-generation design targets sites that </a:t>
             </a:r>
             <a:r>
               <a:rPr b="1" sz="1400" i="1">
                 <a:solidFill>
-                  <a:srgbClr val="840032"/>
-                </a:solidFill>
-                <a:latin typeface="Arial"/>
-                <a:ea typeface="Malgun Gothic"/>
-              </a:rPr>
-              <a:t>한계를 깨는</a:t>
+                  <a:srgbClr val="C00000"/>
+                </a:solidFill>
+                <a:latin typeface="Arial"/>
+                <a:ea typeface="Malgun Gothic"/>
+              </a:rPr>
+              <a:t>break scaling</a:t>
             </a:r>
             <a:r>
               <a:rPr sz="1400" i="1">
@@ -5903,7 +5883,7 @@
                 <a:latin typeface="Arial"/>
                 <a:ea typeface="Malgun Gothic"/>
               </a:rPr>
-              <a:t> 비선형 활성점(다중금속·계면)이 차세대 설계의 표적</a:t>
+              <a:t> — multimetallics and interfaces</a:t>
             </a:r>
           </a:p>
         </p:txBody>
@@ -6257,7 +6237,7 @@
                 <a:ea typeface="Malgun Gothic" panose="020B0600000101010101" pitchFamily="50" charset="-127"/>
                 <a:cs typeface="Arial" panose="020B0604020202020204" pitchFamily="34" charset="0"/>
               </a:rPr>
-              <a:t>ML 스크리닝 → 실험 검증 루프</a:t>
+              <a:t>From ML Screening to Experiment</a:t>
             </a:r>
             <a:endParaRPr kumimoji="1" lang="ko-KR" altLang="en-US" sz="2400" dirty="0">
               <a:latin typeface="Arial" panose="020B0604020202020204" pitchFamily="34" charset="0"/>
@@ -6352,7 +6332,7 @@
                 <a:latin typeface="Arial"/>
                 <a:ea typeface="Malgun Gothic"/>
               </a:rPr>
-              <a:t>① 생성</a:t>
+              <a:t>① Generate</a:t>
             </a:r>
           </a:p>
           <a:p>
@@ -6365,17 +6345,17 @@
                 <a:latin typeface="Arial"/>
                 <a:ea typeface="Malgun Gothic"/>
               </a:rPr>
-              <a:t>조성·표면·결함을 조합해 </a:t>
+              <a:t>Combine compositions, facets, and defects into </a:t>
             </a:r>
             <a:r>
               <a:rPr b="1" sz="1700">
                 <a:solidFill>
-                  <a:srgbClr val="840032"/>
-                </a:solidFill>
-                <a:latin typeface="Arial"/>
-                <a:ea typeface="Malgun Gothic"/>
-              </a:rPr>
-              <a:t>수만 개</a:t>
+                  <a:srgbClr val="C00000"/>
+                </a:solidFill>
+                <a:latin typeface="Arial"/>
+                <a:ea typeface="Malgun Gothic"/>
+              </a:rPr>
+              <a:t>tens of thousands</a:t>
             </a:r>
             <a:r>
               <a:rPr sz="1700" b="0">
@@ -6385,7 +6365,7 @@
                 <a:latin typeface="Arial"/>
                 <a:ea typeface="Malgun Gothic"/>
               </a:rPr>
-              <a:t> 구조 후보를 자동 생성하고 MLIP로 안정성 1차 필터.</a:t>
+              <a:t> of candidate structures; pre-filter stability with an MLIP.</a:t>
             </a:r>
           </a:p>
         </p:txBody>
@@ -6411,7 +6391,7 @@
           </a:solidFill>
           <a:ln w="28575">
             <a:solidFill>
-              <a:srgbClr val="C5A86F"/>
+              <a:srgbClr val="0F0F70"/>
             </a:solidFill>
           </a:ln>
         </p:spPr>
@@ -6436,7 +6416,7 @@
           <a:lstStyle/>
           <a:p>
             <a:pPr algn="ctr" latinLnBrk="0"/>
-            <a:endParaRPr lang="ko-KR" altLang="en-US" dirty="0">
+            <a:endParaRPr lang="ko-KR" altLang="en-US" b="1" dirty="0">
               <a:latin typeface="Arial" panose="020B0604020202020204" pitchFamily="34" charset="0"/>
               <a:ea typeface="맑은 고딕" panose="020B0600000101010101" pitchFamily="50" charset="-127"/>
               <a:cs typeface="Arial" panose="020B0604020202020204" pitchFamily="34" charset="0"/>
@@ -6470,12 +6450,12 @@
             <a:r>
               <a:rPr sz="2000" b="1">
                 <a:solidFill>
-                  <a:srgbClr val="840032"/>
-                </a:solidFill>
-                <a:latin typeface="Arial"/>
-                <a:ea typeface="Malgun Gothic"/>
-              </a:rPr>
-              <a:t>② 예측</a:t>
+                  <a:srgbClr val="0F0F70"/>
+                </a:solidFill>
+                <a:latin typeface="Arial"/>
+                <a:ea typeface="Malgun Gothic"/>
+              </a:rPr>
+              <a:t>② Predict</a:t>
             </a:r>
           </a:p>
           <a:p>
@@ -6488,17 +6468,17 @@
                 <a:latin typeface="Arial"/>
                 <a:ea typeface="Malgun Gothic"/>
               </a:rPr>
-              <a:t>디스크립터·그래프 신경망으로 활성·선택성을 회귀, </a:t>
+              <a:t>Regress activity and selectivity with descriptors and graph neural networks; </a:t>
             </a:r>
             <a:r>
               <a:rPr b="1" sz="1700">
                 <a:solidFill>
-                  <a:srgbClr val="840032"/>
-                </a:solidFill>
-                <a:latin typeface="Arial"/>
-                <a:ea typeface="Malgun Gothic"/>
-              </a:rPr>
-              <a:t>불확실성 정량화</a:t>
+                  <a:srgbClr val="C00000"/>
+                </a:solidFill>
+                <a:latin typeface="Arial"/>
+                <a:ea typeface="Malgun Gothic"/>
+              </a:rPr>
+              <a:t>quantify uncertainty</a:t>
             </a:r>
             <a:r>
               <a:rPr sz="1700" b="0">
@@ -6508,7 +6488,7 @@
                 <a:latin typeface="Arial"/>
                 <a:ea typeface="Malgun Gothic"/>
               </a:rPr>
-              <a:t>로 다음 계산을 능동 선택(active learning).</a:t>
+              <a:t> to actively pick the next calculation (active learning).</a:t>
             </a:r>
           </a:p>
         </p:txBody>
@@ -6598,7 +6578,7 @@
                 <a:latin typeface="Arial"/>
                 <a:ea typeface="Malgun Gothic"/>
               </a:rPr>
-              <a:t>③ 검증</a:t>
+              <a:t>③ Validate</a:t>
             </a:r>
           </a:p>
           <a:p>
@@ -6611,17 +6591,17 @@
                 <a:latin typeface="Arial"/>
                 <a:ea typeface="Malgun Gothic"/>
               </a:rPr>
-              <a:t>상위 후보만 합성·평가해 데이터를 회수, 모델을 재학습하는 </a:t>
+              <a:t>Synthesize and test only the top candidates, return the data, and retrain — a </a:t>
             </a:r>
             <a:r>
               <a:rPr b="1" sz="1700">
                 <a:solidFill>
-                  <a:srgbClr val="840032"/>
-                </a:solidFill>
-                <a:latin typeface="Arial"/>
-                <a:ea typeface="Malgun Gothic"/>
-              </a:rPr>
-              <a:t>closed-loop</a:t>
+                  <a:srgbClr val="C00000"/>
+                </a:solidFill>
+                <a:latin typeface="Arial"/>
+                <a:ea typeface="Malgun Gothic"/>
+              </a:rPr>
+              <a:t>closed loop</a:t>
             </a:r>
             <a:r>
               <a:rPr sz="1700" b="0">
@@ -6631,7 +6611,7 @@
                 <a:latin typeface="Arial"/>
                 <a:ea typeface="Malgun Gothic"/>
               </a:rPr>
-              <a:t>로 발견을 가속.</a:t>
+              <a:t> that accelerates discovery.</a:t>
             </a:r>
           </a:p>
         </p:txBody>
@@ -6666,27 +6646,17 @@
                 <a:latin typeface="Arial"/>
                 <a:ea typeface="Malgun Gothic"/>
               </a:rPr>
-              <a:t>사례: 합금 산소환원 촉매에서 </a:t>
+              <a:t>Case: alloy oxygen-reduction catalysts compressed from </a:t>
             </a:r>
             <a:r>
               <a:rPr b="1" sz="1400" i="1">
                 <a:solidFill>
-                  <a:srgbClr val="840032"/>
-                </a:solidFill>
-                <a:latin typeface="Arial"/>
-                <a:ea typeface="Malgun Gothic"/>
-              </a:rPr>
-              <a:t>후보 1만 → 실험 10여 개</a:t>
-            </a:r>
-            <a:r>
-              <a:rPr sz="1400" i="1">
-                <a:solidFill>
-                  <a:srgbClr val="697A82"/>
-                </a:solidFill>
-                <a:latin typeface="Arial"/>
-                <a:ea typeface="Malgun Gothic"/>
-              </a:rPr>
-              <a:t>로 압축</a:t>
+                  <a:srgbClr val="C00000"/>
+                </a:solidFill>
+                <a:latin typeface="Arial"/>
+                <a:ea typeface="Malgun Gothic"/>
+              </a:rPr>
+              <a:t>10,000 candidates to ~10 experiments</a:t>
             </a:r>
           </a:p>
         </p:txBody>
@@ -6797,7 +6767,7 @@
                 <a:latin typeface="Arial"/>
                 <a:ea typeface="Malgun Gothic"/>
               </a:rPr>
-              <a:t>계산화학 × 머신러닝으로 촉매 설계의 탐색 공간을 좁힌다</a:t>
+              <a:t>Computation × machine learning narrows the search space of catalyst design</a:t>
             </a:r>
           </a:p>
         </p:txBody>

</xml_diff>

<commit_message>
snu theme: pure black (#000000) body/ink text
</commit_message>
<xml_diff>
--- a/samples/benchmark_catalysis_deck.pptx
+++ b/samples/benchmark_catalysis_deck.pptx
@@ -3287,7 +3287,7 @@
             <a:r>
               <a:rPr sz="2000" b="0">
                 <a:solidFill>
-                  <a:srgbClr val="1A1A1A"/>
+                  <a:srgbClr val="000000"/>
                 </a:solidFill>
                 <a:latin typeface="Arial"/>
                 <a:ea typeface="Malgun Gothic"/>
@@ -3879,7 +3879,7 @@
             <a:r>
               <a:rPr sz="1700" b="0">
                 <a:solidFill>
-                  <a:srgbClr val="1A1A1A"/>
+                  <a:srgbClr val="000000"/>
                 </a:solidFill>
                 <a:latin typeface="Arial"/>
                 <a:ea typeface="Malgun Gothic"/>
@@ -3899,7 +3899,7 @@
             <a:r>
               <a:rPr sz="1700" b="0">
                 <a:solidFill>
-                  <a:srgbClr val="1A1A1A"/>
+                  <a:srgbClr val="000000"/>
                 </a:solidFill>
                 <a:latin typeface="Arial"/>
                 <a:ea typeface="Malgun Gothic"/>
@@ -3936,7 +3936,7 @@
             <a:r>
               <a:rPr sz="1700" b="0">
                 <a:solidFill>
-                  <a:srgbClr val="1A1A1A"/>
+                  <a:srgbClr val="000000"/>
                 </a:solidFill>
                 <a:latin typeface="Arial"/>
                 <a:ea typeface="Malgun Gothic"/>
@@ -3956,7 +3956,7 @@
             <a:r>
               <a:rPr sz="1700" b="0">
                 <a:solidFill>
-                  <a:srgbClr val="1A1A1A"/>
+                  <a:srgbClr val="000000"/>
                 </a:solidFill>
                 <a:latin typeface="Arial"/>
                 <a:ea typeface="Malgun Gothic"/>
@@ -3983,7 +3983,7 @@
             <a:r>
               <a:rPr sz="1700" b="0">
                 <a:solidFill>
-                  <a:srgbClr val="1A1A1A"/>
+                  <a:srgbClr val="000000"/>
                 </a:solidFill>
                 <a:latin typeface="Arial"/>
                 <a:ea typeface="Malgun Gothic"/>
@@ -4003,7 +4003,7 @@
             <a:r>
               <a:rPr sz="1700" b="0">
                 <a:solidFill>
-                  <a:srgbClr val="1A1A1A"/>
+                  <a:srgbClr val="000000"/>
                 </a:solidFill>
                 <a:latin typeface="Arial"/>
                 <a:ea typeface="Malgun Gothic"/>
@@ -4049,7 +4049,7 @@
             <a:r>
               <a:rPr sz="1700" b="0">
                 <a:solidFill>
-                  <a:srgbClr val="1A1A1A"/>
+                  <a:srgbClr val="000000"/>
                 </a:solidFill>
                 <a:latin typeface="Arial"/>
                 <a:ea typeface="Malgun Gothic"/>
@@ -4069,7 +4069,7 @@
             <a:r>
               <a:rPr sz="1700" b="0">
                 <a:solidFill>
-                  <a:srgbClr val="1A1A1A"/>
+                  <a:srgbClr val="000000"/>
                 </a:solidFill>
                 <a:latin typeface="Arial"/>
                 <a:ea typeface="Malgun Gothic"/>
@@ -4089,7 +4089,7 @@
             <a:r>
               <a:rPr sz="1700" b="0">
                 <a:solidFill>
-                  <a:srgbClr val="1A1A1A"/>
+                  <a:srgbClr val="000000"/>
                 </a:solidFill>
                 <a:latin typeface="Arial"/>
                 <a:ea typeface="Malgun Gothic"/>
@@ -4109,7 +4109,7 @@
             <a:r>
               <a:rPr sz="1700" b="0">
                 <a:solidFill>
-                  <a:srgbClr val="1A1A1A"/>
+                  <a:srgbClr val="000000"/>
                 </a:solidFill>
                 <a:latin typeface="Arial"/>
                 <a:ea typeface="Malgun Gothic"/>
@@ -4616,7 +4616,7 @@
             <a:r>
               <a:rPr sz="1700" b="0">
                 <a:solidFill>
-                  <a:srgbClr val="1A1A1A"/>
+                  <a:srgbClr val="000000"/>
                 </a:solidFill>
                 <a:latin typeface="Arial"/>
                 <a:ea typeface="Malgun Gothic"/>
@@ -4636,7 +4636,7 @@
             <a:r>
               <a:rPr sz="1700" b="0">
                 <a:solidFill>
-                  <a:srgbClr val="1A1A1A"/>
+                  <a:srgbClr val="000000"/>
                 </a:solidFill>
                 <a:latin typeface="Arial"/>
                 <a:ea typeface="Malgun Gothic"/>
@@ -4656,7 +4656,7 @@
             <a:r>
               <a:rPr sz="1700" b="0">
                 <a:solidFill>
-                  <a:srgbClr val="1A1A1A"/>
+                  <a:srgbClr val="000000"/>
                 </a:solidFill>
                 <a:latin typeface="Arial"/>
                 <a:ea typeface="Malgun Gothic"/>
@@ -4769,7 +4769,7 @@
             <a:r>
               <a:rPr sz="1700" b="0">
                 <a:solidFill>
-                  <a:srgbClr val="1A1A1A"/>
+                  <a:srgbClr val="000000"/>
                 </a:solidFill>
                 <a:latin typeface="Arial"/>
                 <a:ea typeface="Malgun Gothic"/>
@@ -4789,7 +4789,7 @@
             <a:r>
               <a:rPr sz="1700" b="0">
                 <a:solidFill>
-                  <a:srgbClr val="1A1A1A"/>
+                  <a:srgbClr val="000000"/>
                 </a:solidFill>
                 <a:latin typeface="Arial"/>
                 <a:ea typeface="Malgun Gothic"/>
@@ -4892,7 +4892,7 @@
             <a:r>
               <a:rPr sz="1700" b="0">
                 <a:solidFill>
-                  <a:srgbClr val="1A1A1A"/>
+                  <a:srgbClr val="000000"/>
                 </a:solidFill>
                 <a:latin typeface="Arial"/>
                 <a:ea typeface="Malgun Gothic"/>
@@ -4912,7 +4912,7 @@
             <a:r>
               <a:rPr sz="1700" b="0">
                 <a:solidFill>
-                  <a:srgbClr val="1A1A1A"/>
+                  <a:srgbClr val="000000"/>
                 </a:solidFill>
                 <a:latin typeface="Arial"/>
                 <a:ea typeface="Malgun Gothic"/>
@@ -4932,7 +4932,7 @@
             <a:r>
               <a:rPr sz="1700" b="0">
                 <a:solidFill>
-                  <a:srgbClr val="1A1A1A"/>
+                  <a:srgbClr val="000000"/>
                 </a:solidFill>
                 <a:latin typeface="Arial"/>
                 <a:ea typeface="Malgun Gothic"/>
@@ -5516,7 +5516,7 @@
             <a:r>
               <a:rPr sz="1700" b="0">
                 <a:solidFill>
-                  <a:srgbClr val="1A1A1A"/>
+                  <a:srgbClr val="000000"/>
                 </a:solidFill>
                 <a:latin typeface="Arial"/>
                 <a:ea typeface="Malgun Gothic"/>
@@ -5536,7 +5536,7 @@
             <a:r>
               <a:rPr sz="1700" b="0">
                 <a:solidFill>
-                  <a:srgbClr val="1A1A1A"/>
+                  <a:srgbClr val="000000"/>
                 </a:solidFill>
                 <a:latin typeface="Arial"/>
                 <a:ea typeface="Malgun Gothic"/>
@@ -5556,7 +5556,7 @@
             <a:r>
               <a:rPr sz="1700" b="0">
                 <a:solidFill>
-                  <a:srgbClr val="1A1A1A"/>
+                  <a:srgbClr val="000000"/>
                 </a:solidFill>
                 <a:latin typeface="Arial"/>
                 <a:ea typeface="Malgun Gothic"/>
@@ -5659,7 +5659,7 @@
             <a:r>
               <a:rPr sz="1700" b="0">
                 <a:solidFill>
-                  <a:srgbClr val="1A1A1A"/>
+                  <a:srgbClr val="000000"/>
                 </a:solidFill>
                 <a:latin typeface="Arial"/>
                 <a:ea typeface="Malgun Gothic"/>
@@ -5679,7 +5679,7 @@
             <a:r>
               <a:rPr sz="1700" b="0">
                 <a:solidFill>
-                  <a:srgbClr val="1A1A1A"/>
+                  <a:srgbClr val="000000"/>
                 </a:solidFill>
                 <a:latin typeface="Arial"/>
                 <a:ea typeface="Malgun Gothic"/>
@@ -6340,7 +6340,7 @@
             <a:r>
               <a:rPr sz="1700" b="0">
                 <a:solidFill>
-                  <a:srgbClr val="1A1A1A"/>
+                  <a:srgbClr val="000000"/>
                 </a:solidFill>
                 <a:latin typeface="Arial"/>
                 <a:ea typeface="Malgun Gothic"/>
@@ -6360,7 +6360,7 @@
             <a:r>
               <a:rPr sz="1700" b="0">
                 <a:solidFill>
-                  <a:srgbClr val="1A1A1A"/>
+                  <a:srgbClr val="000000"/>
                 </a:solidFill>
                 <a:latin typeface="Arial"/>
                 <a:ea typeface="Malgun Gothic"/>
@@ -6463,7 +6463,7 @@
             <a:r>
               <a:rPr sz="1700" b="0">
                 <a:solidFill>
-                  <a:srgbClr val="1A1A1A"/>
+                  <a:srgbClr val="000000"/>
                 </a:solidFill>
                 <a:latin typeface="Arial"/>
                 <a:ea typeface="Malgun Gothic"/>
@@ -6483,7 +6483,7 @@
             <a:r>
               <a:rPr sz="1700" b="0">
                 <a:solidFill>
-                  <a:srgbClr val="1A1A1A"/>
+                  <a:srgbClr val="000000"/>
                 </a:solidFill>
                 <a:latin typeface="Arial"/>
                 <a:ea typeface="Malgun Gothic"/>
@@ -6586,7 +6586,7 @@
             <a:r>
               <a:rPr sz="1700" b="0">
                 <a:solidFill>
-                  <a:srgbClr val="1A1A1A"/>
+                  <a:srgbClr val="000000"/>
                 </a:solidFill>
                 <a:latin typeface="Arial"/>
                 <a:ea typeface="Malgun Gothic"/>
@@ -6606,7 +6606,7 @@
             <a:r>
               <a:rPr sz="1700" b="0">
                 <a:solidFill>
-                  <a:srgbClr val="1A1A1A"/>
+                  <a:srgbClr val="000000"/>
                 </a:solidFill>
                 <a:latin typeface="Arial"/>
                 <a:ea typeface="Malgun Gothic"/>

</xml_diff>

<commit_message>
snu theme: fade banner tint further + navy check-bullet
- banner gradient navy tint alpha 0.035 -> 0.012, fades to transparent by 55%
- check-bullet marker uses new check_color token (snu: navy, fallback gold)
</commit_message>
<xml_diff>
--- a/samples/benchmark_catalysis_deck.pptx
+++ b/samples/benchmark_catalysis_deck.pptx
@@ -3869,7 +3869,7 @@
             <a:r>
               <a:rPr sz="1700" b="1">
                 <a:solidFill>
-                  <a:srgbClr val="C5A86F"/>
+                  <a:srgbClr val="0F0F70"/>
                 </a:solidFill>
                 <a:latin typeface="Arial"/>
                 <a:ea typeface="Malgun Gothic"/>
@@ -3926,7 +3926,7 @@
             <a:r>
               <a:rPr sz="1700" b="1">
                 <a:solidFill>
-                  <a:srgbClr val="C5A86F"/>
+                  <a:srgbClr val="0F0F70"/>
                 </a:solidFill>
                 <a:latin typeface="Arial"/>
                 <a:ea typeface="Malgun Gothic"/>
@@ -3973,7 +3973,7 @@
             <a:r>
               <a:rPr sz="1700" b="1">
                 <a:solidFill>
-                  <a:srgbClr val="C5A86F"/>
+                  <a:srgbClr val="0F0F70"/>
                 </a:solidFill>
                 <a:latin typeface="Arial"/>
                 <a:ea typeface="Malgun Gothic"/>

</xml_diff>

<commit_message>
snu deck: align banner title to gold pill, darker gray banner, new lab title
- generate.py .title: top 0/h84 -> top 27/h52 so the HTML banner title centers on
  the gold X.Y pill row (matches the PPT 26.7/52.3 placement)
- snu banner gradient: visible light-gray (#CFCFCF -> #F7F7F7), not near-white
- benchmark title -> 'Computational Catalysis and Emerging Materials Laboratory'
</commit_message>
<xml_diff>
--- a/samples/benchmark_catalysis_deck.pptx
+++ b/samples/benchmark_catalysis_deck.pptx
@@ -3189,8 +3189,8 @@
         </p:nvSpPr>
         <p:spPr>
           <a:xfrm>
-            <a:off x="857250" y="2306955"/>
-            <a:ext cx="10477500" cy="675640"/>
+            <a:off x="857250" y="2007234"/>
+            <a:ext cx="10477500" cy="1275080"/>
           </a:xfrm>
           <a:prstGeom prst="rect">
             <a:avLst/>
@@ -3212,7 +3212,7 @@
                 <a:latin typeface="Arial"/>
                 <a:ea typeface="Malgun Gothic"/>
               </a:rPr>
-              <a:t>Computational Chemistry for Catalysis</a:t>
+              <a:t>Computational Catalysis and Emerging Materials Laboratory</a:t>
             </a:r>
           </a:p>
         </p:txBody>
@@ -3225,7 +3225,7 @@
         </p:nvSpPr>
         <p:spPr>
           <a:xfrm>
-            <a:off x="857250" y="3020695"/>
+            <a:off x="857250" y="3320414"/>
             <a:ext cx="800100" cy="38100"/>
           </a:xfrm>
           <a:prstGeom prst="rect">
@@ -3269,7 +3269,7 @@
         </p:nvSpPr>
         <p:spPr>
           <a:xfrm>
-            <a:off x="857250" y="3154045"/>
+            <a:off x="857250" y="3453764"/>
             <a:ext cx="10477500" cy="406400"/>
           </a:xfrm>
           <a:prstGeom prst="rect">

</xml_diff>